<commit_message>
Readable Ceará map: shoreline clip, 65% cells, municipality labels, locator inset, boundary hover names; corrected figures in paper, memo and slide
</commit_message>
<xml_diff>
--- a/docs/SCN_Phases_and_Data.pptx
+++ b/docs/SCN_Phases_and_Data.pptx
@@ -502,7 +502,7 @@
           <a:p>
             <a:r>
               <a:rPr lang="en-US" dirty="0"/>
-              <a:t>Phase 1 harmonizes all layers onto 2,808 H3 resolution-8 cells and applies hard exclusions (conservation units, indigenous lands, surface water, outside state). Phase 2 derives the degradation probability from quarterly Sentinel-2 and Sentinel-1 composites. Phase 3 is a deterministic policy classifier built from the 36-document corpus; boundaries are reused for the 2.5 km human-review buffer. Phase 4 applies the operator constraints (HV bus within 25 km, line within 15 km, interconnection facility within 50 km) and sorts survivors on a six-objective Pareto frontier: 819 feasible, 448 on the frontier, 25 recommended.</a:t>
+              <a:t>Phase 1 harmonizes all layers onto 2,808 H3 resolution-8 cells and applies hard exclusions (conservation units, indigenous lands, surface water, outside state). Phase 2 derives the degradation probability from quarterly Sentinel-2 and Sentinel-1 composites. Phase 3 is a deterministic policy classifier built from the 36-document corpus; boundaries are reused for the 2.5 km human-review buffer. Phase 4 applies the operator constraints (HV bus within 25 km, line within 15 km, interconnection facility within 50 km) and sorts survivors on a six-objective Pareto frontier: 966 feasible, 505 on the frontier, 25 recommended (after the September 2026 zero-distance fix; the pre-fix run gave 819 / 448 / 25).</a:t>
             </a:r>
             <a:endParaRPr lang="en-US" dirty="0"/>
           </a:p>
@@ -2708,7 +2708,7 @@
                 <a:ea typeface="Calibri" pitchFamily="34" charset="-122"/>
                 <a:cs typeface="Calibri" pitchFamily="34" charset="-120"/>
               </a:rPr>
-              <a:t>819 → 448 → 25 sites</a:t>
+              <a:t>966 → 505 → 25 sites</a:t>
             </a:r>
             <a:endParaRPr lang="en-US" sz="1200" dirty="0"/>
           </a:p>

</xml_diff>